<commit_message>
Child Category- Show created data at datatables
</commit_message>
<xml_diff>
--- a/.lessons/56 Category, Subcategory and Child Category Setup/15 Child Category- working with child category (part - 2)/1.pptx
+++ b/.lessons/56 Category, Subcategory and Child Category Setup/15 Child Category- working with child category (part - 2)/1.pptx
@@ -7,7 +7,15 @@
   <p:sldIdLst>
     <p:sldId id="413" r:id="rId2"/>
     <p:sldId id="414" r:id="rId3"/>
-    <p:sldId id="400" r:id="rId4"/>
+    <p:sldId id="415" r:id="rId4"/>
+    <p:sldId id="416" r:id="rId5"/>
+    <p:sldId id="417" r:id="rId6"/>
+    <p:sldId id="418" r:id="rId7"/>
+    <p:sldId id="419" r:id="rId8"/>
+    <p:sldId id="420" r:id="rId9"/>
+    <p:sldId id="421" r:id="rId10"/>
+    <p:sldId id="422" r:id="rId11"/>
+    <p:sldId id="400" r:id="rId12"/>
   </p:sldIdLst>
   <p:sldSz cx="12192000" cy="6858000"/>
   <p:notesSz cx="6858000" cy="9144000"/>
@@ -261,7 +269,7 @@
           <a:p>
             <a:fld id="{3E102D2E-813C-461C-9963-687A650C48C0}" type="datetimeFigureOut">
               <a:rPr lang="en-US" smtClean="0"/>
-              <a:t>6/26/2025</a:t>
+              <a:t>8/27/2025</a:t>
             </a:fld>
             <a:endParaRPr lang="en-US"/>
           </a:p>
@@ -459,7 +467,7 @@
           <a:p>
             <a:fld id="{3E102D2E-813C-461C-9963-687A650C48C0}" type="datetimeFigureOut">
               <a:rPr lang="en-US" smtClean="0"/>
-              <a:t>6/26/2025</a:t>
+              <a:t>8/27/2025</a:t>
             </a:fld>
             <a:endParaRPr lang="en-US"/>
           </a:p>
@@ -667,7 +675,7 @@
           <a:p>
             <a:fld id="{3E102D2E-813C-461C-9963-687A650C48C0}" type="datetimeFigureOut">
               <a:rPr lang="en-US" smtClean="0"/>
-              <a:t>6/26/2025</a:t>
+              <a:t>8/27/2025</a:t>
             </a:fld>
             <a:endParaRPr lang="en-US"/>
           </a:p>
@@ -865,7 +873,7 @@
           <a:p>
             <a:fld id="{3E102D2E-813C-461C-9963-687A650C48C0}" type="datetimeFigureOut">
               <a:rPr lang="en-US" smtClean="0"/>
-              <a:t>6/26/2025</a:t>
+              <a:t>8/27/2025</a:t>
             </a:fld>
             <a:endParaRPr lang="en-US"/>
           </a:p>
@@ -1140,7 +1148,7 @@
           <a:p>
             <a:fld id="{3E102D2E-813C-461C-9963-687A650C48C0}" type="datetimeFigureOut">
               <a:rPr lang="en-US" smtClean="0"/>
-              <a:t>6/26/2025</a:t>
+              <a:t>8/27/2025</a:t>
             </a:fld>
             <a:endParaRPr lang="en-US"/>
           </a:p>
@@ -1405,7 +1413,7 @@
           <a:p>
             <a:fld id="{3E102D2E-813C-461C-9963-687A650C48C0}" type="datetimeFigureOut">
               <a:rPr lang="en-US" smtClean="0"/>
-              <a:t>6/26/2025</a:t>
+              <a:t>8/27/2025</a:t>
             </a:fld>
             <a:endParaRPr lang="en-US"/>
           </a:p>
@@ -1817,7 +1825,7 @@
           <a:p>
             <a:fld id="{3E102D2E-813C-461C-9963-687A650C48C0}" type="datetimeFigureOut">
               <a:rPr lang="en-US" smtClean="0"/>
-              <a:t>6/26/2025</a:t>
+              <a:t>8/27/2025</a:t>
             </a:fld>
             <a:endParaRPr lang="en-US"/>
           </a:p>
@@ -1958,7 +1966,7 @@
           <a:p>
             <a:fld id="{3E102D2E-813C-461C-9963-687A650C48C0}" type="datetimeFigureOut">
               <a:rPr lang="en-US" smtClean="0"/>
-              <a:t>6/26/2025</a:t>
+              <a:t>8/27/2025</a:t>
             </a:fld>
             <a:endParaRPr lang="en-US"/>
           </a:p>
@@ -2071,7 +2079,7 @@
           <a:p>
             <a:fld id="{3E102D2E-813C-461C-9963-687A650C48C0}" type="datetimeFigureOut">
               <a:rPr lang="en-US" smtClean="0"/>
-              <a:t>6/26/2025</a:t>
+              <a:t>8/27/2025</a:t>
             </a:fld>
             <a:endParaRPr lang="en-US"/>
           </a:p>
@@ -2382,7 +2390,7 @@
           <a:p>
             <a:fld id="{3E102D2E-813C-461C-9963-687A650C48C0}" type="datetimeFigureOut">
               <a:rPr lang="en-US" smtClean="0"/>
-              <a:t>6/26/2025</a:t>
+              <a:t>8/27/2025</a:t>
             </a:fld>
             <a:endParaRPr lang="en-US"/>
           </a:p>
@@ -2670,7 +2678,7 @@
           <a:p>
             <a:fld id="{3E102D2E-813C-461C-9963-687A650C48C0}" type="datetimeFigureOut">
               <a:rPr lang="en-US" smtClean="0"/>
-              <a:t>6/26/2025</a:t>
+              <a:t>8/27/2025</a:t>
             </a:fld>
             <a:endParaRPr lang="en-US"/>
           </a:p>
@@ -2911,7 +2919,7 @@
           <a:p>
             <a:fld id="{3E102D2E-813C-461C-9963-687A650C48C0}" type="datetimeFigureOut">
               <a:rPr lang="en-US" smtClean="0"/>
-              <a:t>6/26/2025</a:t>
+              <a:t>8/27/2025</a:t>
             </a:fld>
             <a:endParaRPr lang="en-US"/>
           </a:p>
@@ -3349,6 +3357,151 @@
         <p:spPr>
           <a:xfrm>
             <a:off x="217714" y="255046"/>
+            <a:ext cx="11756571" cy="955518"/>
+          </a:xfrm>
+          <a:prstGeom prst="rect">
+            <a:avLst/>
+          </a:prstGeom>
+          <a:noFill/>
+        </p:spPr>
+        <p:txBody>
+          <a:bodyPr wrap="square">
+            <a:spAutoFit/>
+          </a:bodyPr>
+          <a:lstStyle/>
+          <a:p>
+            <a:pPr>
+              <a:lnSpc>
+                <a:spcPct val="150000"/>
+              </a:lnSpc>
+              <a:buNone/>
+            </a:pPr>
+            <a:r>
+              <a:rPr lang="en-US" altLang="en-US" sz="1300">
+                <a:latin typeface="Arial" panose="020B0604020202020204" pitchFamily="34" charset="0"/>
+              </a:rPr>
+              <a:t>resources\views\admin\child-category\create.blade.php</a:t>
+            </a:r>
+          </a:p>
+          <a:p>
+            <a:pPr>
+              <a:lnSpc>
+                <a:spcPct val="150000"/>
+              </a:lnSpc>
+              <a:buNone/>
+            </a:pPr>
+            <a:endParaRPr kumimoji="0" lang="en-US" altLang="en-US" sz="1300" b="0" i="0" u="none" strike="noStrike" cap="none" normalizeH="0" baseline="0">
+              <a:ln>
+                <a:noFill/>
+              </a:ln>
+              <a:solidFill>
+                <a:schemeClr val="tx1"/>
+              </a:solidFill>
+              <a:effectLst/>
+              <a:latin typeface="Arial" panose="020B0604020202020204" pitchFamily="34" charset="0"/>
+            </a:endParaRPr>
+          </a:p>
+          <a:p>
+            <a:pPr>
+              <a:lnSpc>
+                <a:spcPct val="150000"/>
+              </a:lnSpc>
+              <a:buNone/>
+            </a:pPr>
+            <a:endParaRPr kumimoji="0" lang="en-US" altLang="en-US" sz="1300" b="0" i="0" u="none" strike="noStrike" cap="none" normalizeH="0" baseline="0">
+              <a:ln>
+                <a:noFill/>
+              </a:ln>
+              <a:solidFill>
+                <a:schemeClr val="tx1"/>
+              </a:solidFill>
+              <a:effectLst/>
+              <a:latin typeface="Arial" panose="020B0604020202020204" pitchFamily="34" charset="0"/>
+            </a:endParaRPr>
+          </a:p>
+        </p:txBody>
+      </p:sp>
+      <p:pic>
+        <p:nvPicPr>
+          <p:cNvPr id="6" name="Picture 5">
+            <a:extLst>
+              <a:ext uri="{FF2B5EF4-FFF2-40B4-BE49-F238E27FC236}">
+                <a16:creationId xmlns:a16="http://schemas.microsoft.com/office/drawing/2014/main" id="{496A894F-1135-3BF0-2B79-CC269EBA1B62}"/>
+              </a:ext>
+            </a:extLst>
+          </p:cNvPr>
+          <p:cNvPicPr>
+            <a:picLocks noChangeAspect="1"/>
+          </p:cNvPicPr>
+          <p:nvPr/>
+        </p:nvPicPr>
+        <p:blipFill>
+          <a:blip r:embed="rId2"/>
+          <a:stretch>
+            <a:fillRect/>
+          </a:stretch>
+        </p:blipFill>
+        <p:spPr>
+          <a:xfrm>
+            <a:off x="5269840" y="0"/>
+            <a:ext cx="6922160" cy="6858000"/>
+          </a:xfrm>
+          <a:prstGeom prst="rect">
+            <a:avLst/>
+          </a:prstGeom>
+        </p:spPr>
+      </p:pic>
+    </p:spTree>
+    <p:extLst>
+      <p:ext uri="{BB962C8B-B14F-4D97-AF65-F5344CB8AC3E}">
+        <p14:creationId xmlns:p14="http://schemas.microsoft.com/office/powerpoint/2010/main" val="3863838039"/>
+      </p:ext>
+    </p:extLst>
+  </p:cSld>
+  <p:clrMapOvr>
+    <a:masterClrMapping/>
+  </p:clrMapOvr>
+</p:sld>
+</file>
+
+<file path=ppt/slides/slide10.xml><?xml version="1.0" encoding="utf-8"?>
+<p:sld xmlns:a="http://schemas.openxmlformats.org/drawingml/2006/main" xmlns:r="http://schemas.openxmlformats.org/officeDocument/2006/relationships" xmlns:p="http://schemas.openxmlformats.org/presentationml/2006/main">
+  <p:cSld>
+    <p:spTree>
+      <p:nvGrpSpPr>
+        <p:cNvPr id="1" name="">
+          <a:extLst>
+            <a:ext uri="{FF2B5EF4-FFF2-40B4-BE49-F238E27FC236}">
+              <a16:creationId xmlns:a16="http://schemas.microsoft.com/office/drawing/2014/main" id="{F9DB377A-5DFC-C8D0-186F-F2686D542B05}"/>
+            </a:ext>
+          </a:extLst>
+        </p:cNvPr>
+        <p:cNvGrpSpPr/>
+        <p:nvPr/>
+      </p:nvGrpSpPr>
+      <p:grpSpPr>
+        <a:xfrm>
+          <a:off x="0" y="0"/>
+          <a:ext cx="0" cy="0"/>
+          <a:chOff x="0" y="0"/>
+          <a:chExt cx="0" cy="0"/>
+        </a:xfrm>
+      </p:grpSpPr>
+      <p:sp>
+        <p:nvSpPr>
+          <p:cNvPr id="3" name="TextBox 2">
+            <a:extLst>
+              <a:ext uri="{FF2B5EF4-FFF2-40B4-BE49-F238E27FC236}">
+                <a16:creationId xmlns:a16="http://schemas.microsoft.com/office/drawing/2014/main" id="{96E3584D-4572-9452-DAC3-7D6309F4160B}"/>
+              </a:ext>
+            </a:extLst>
+          </p:cNvPr>
+          <p:cNvSpPr txBox="1"/>
+          <p:nvPr/>
+        </p:nvSpPr>
+        <p:spPr>
+          <a:xfrm>
+            <a:off x="217714" y="255046"/>
             <a:ext cx="11756571" cy="355354"/>
           </a:xfrm>
           <a:prstGeom prst="rect">
@@ -3387,7 +3540,93 @@
     </p:spTree>
     <p:extLst>
       <p:ext uri="{BB962C8B-B14F-4D97-AF65-F5344CB8AC3E}">
-        <p14:creationId xmlns:p14="http://schemas.microsoft.com/office/powerpoint/2010/main" val="3863838039"/>
+        <p14:creationId xmlns:p14="http://schemas.microsoft.com/office/powerpoint/2010/main" val="2576273079"/>
+      </p:ext>
+    </p:extLst>
+  </p:cSld>
+  <p:clrMapOvr>
+    <a:masterClrMapping/>
+  </p:clrMapOvr>
+</p:sld>
+</file>
+
+<file path=ppt/slides/slide11.xml><?xml version="1.0" encoding="utf-8"?>
+<p:sld xmlns:a="http://schemas.openxmlformats.org/drawingml/2006/main" xmlns:r="http://schemas.openxmlformats.org/officeDocument/2006/relationships" xmlns:p="http://schemas.openxmlformats.org/presentationml/2006/main">
+  <p:cSld>
+    <p:spTree>
+      <p:nvGrpSpPr>
+        <p:cNvPr id="1" name="">
+          <a:extLst>
+            <a:ext uri="{FF2B5EF4-FFF2-40B4-BE49-F238E27FC236}">
+              <a16:creationId xmlns:a16="http://schemas.microsoft.com/office/drawing/2014/main" id="{ECE25D7D-A080-F22B-7E8D-36EC827289A1}"/>
+            </a:ext>
+          </a:extLst>
+        </p:cNvPr>
+        <p:cNvGrpSpPr/>
+        <p:nvPr/>
+      </p:nvGrpSpPr>
+      <p:grpSpPr>
+        <a:xfrm>
+          <a:off x="0" y="0"/>
+          <a:ext cx="0" cy="0"/>
+          <a:chOff x="0" y="0"/>
+          <a:chExt cx="0" cy="0"/>
+        </a:xfrm>
+      </p:grpSpPr>
+      <p:sp>
+        <p:nvSpPr>
+          <p:cNvPr id="3" name="TextBox 2">
+            <a:extLst>
+              <a:ext uri="{FF2B5EF4-FFF2-40B4-BE49-F238E27FC236}">
+                <a16:creationId xmlns:a16="http://schemas.microsoft.com/office/drawing/2014/main" id="{E33F16A3-A6E8-401E-847B-09570DC6E4CB}"/>
+              </a:ext>
+            </a:extLst>
+          </p:cNvPr>
+          <p:cNvSpPr txBox="1"/>
+          <p:nvPr/>
+        </p:nvSpPr>
+        <p:spPr>
+          <a:xfrm>
+            <a:off x="217714" y="255046"/>
+            <a:ext cx="11756571" cy="355354"/>
+          </a:xfrm>
+          <a:prstGeom prst="rect">
+            <a:avLst/>
+          </a:prstGeom>
+          <a:noFill/>
+        </p:spPr>
+        <p:txBody>
+          <a:bodyPr wrap="square">
+            <a:spAutoFit/>
+          </a:bodyPr>
+          <a:lstStyle/>
+          <a:p>
+            <a:pPr>
+              <a:lnSpc>
+                <a:spcPct val="150000"/>
+              </a:lnSpc>
+              <a:buNone/>
+            </a:pPr>
+            <a:r>
+              <a:rPr kumimoji="0" lang="en-US" altLang="en-US" sz="1300" b="0" i="0" u="none" strike="noStrike" cap="none" normalizeH="0" baseline="0">
+                <a:ln>
+                  <a:noFill/>
+                </a:ln>
+                <a:solidFill>
+                  <a:schemeClr val="tx1"/>
+                </a:solidFill>
+                <a:effectLst/>
+                <a:latin typeface="Arial" panose="020B0604020202020204" pitchFamily="34" charset="0"/>
+              </a:rPr>
+              <a:t>.</a:t>
+            </a:r>
+          </a:p>
+        </p:txBody>
+      </p:sp>
+    </p:spTree>
+    <p:extLst>
+      <p:ext uri="{BB962C8B-B14F-4D97-AF65-F5344CB8AC3E}">
+        <p14:creationId xmlns:p14="http://schemas.microsoft.com/office/powerpoint/2010/main" val="3095838342"/>
       </p:ext>
     </p:extLst>
   </p:cSld>
@@ -3455,21 +3694,54 @@
               <a:buNone/>
             </a:pPr>
             <a:r>
-              <a:rPr kumimoji="0" lang="en-US" altLang="en-US" sz="1300" b="0" i="0" u="none" strike="noStrike" cap="none" normalizeH="0" baseline="0">
-                <a:ln>
-                  <a:noFill/>
-                </a:ln>
-                <a:solidFill>
-                  <a:schemeClr val="tx1"/>
-                </a:solidFill>
-                <a:effectLst/>
+              <a:rPr lang="en-US" altLang="en-US" sz="1300">
                 <a:latin typeface="Arial" panose="020B0604020202020204" pitchFamily="34" charset="0"/>
               </a:rPr>
-              <a:t>.</a:t>
-            </a:r>
-          </a:p>
-        </p:txBody>
-      </p:sp>
+              <a:t>database\migrations\2025_08_23_043341_create_child_categories_table.php</a:t>
+            </a:r>
+            <a:endParaRPr kumimoji="0" lang="en-US" altLang="en-US" sz="1300" b="0" i="0" u="none" strike="noStrike" cap="none" normalizeH="0" baseline="0">
+              <a:ln>
+                <a:noFill/>
+              </a:ln>
+              <a:solidFill>
+                <a:schemeClr val="tx1"/>
+              </a:solidFill>
+              <a:effectLst/>
+              <a:latin typeface="Arial" panose="020B0604020202020204" pitchFamily="34" charset="0"/>
+            </a:endParaRPr>
+          </a:p>
+        </p:txBody>
+      </p:sp>
+      <p:pic>
+        <p:nvPicPr>
+          <p:cNvPr id="4" name="Picture 3">
+            <a:extLst>
+              <a:ext uri="{FF2B5EF4-FFF2-40B4-BE49-F238E27FC236}">
+                <a16:creationId xmlns:a16="http://schemas.microsoft.com/office/drawing/2014/main" id="{E45B3341-B738-8F41-AC2C-DBEA3546201B}"/>
+              </a:ext>
+            </a:extLst>
+          </p:cNvPr>
+          <p:cNvPicPr>
+            <a:picLocks noChangeAspect="1"/>
+          </p:cNvPicPr>
+          <p:nvPr/>
+        </p:nvPicPr>
+        <p:blipFill>
+          <a:blip r:embed="rId2"/>
+          <a:stretch>
+            <a:fillRect/>
+          </a:stretch>
+        </p:blipFill>
+        <p:spPr>
+          <a:xfrm>
+            <a:off x="5818886" y="846886"/>
+            <a:ext cx="6373114" cy="6011114"/>
+          </a:xfrm>
+          <a:prstGeom prst="rect">
+            <a:avLst/>
+          </a:prstGeom>
+        </p:spPr>
+      </p:pic>
     </p:spTree>
     <p:extLst>
       <p:ext uri="{BB962C8B-B14F-4D97-AF65-F5344CB8AC3E}">
@@ -3491,7 +3763,7 @@
         <p:cNvPr id="1" name="">
           <a:extLst>
             <a:ext uri="{FF2B5EF4-FFF2-40B4-BE49-F238E27FC236}">
-              <a16:creationId xmlns:a16="http://schemas.microsoft.com/office/drawing/2014/main" id="{ECE25D7D-A080-F22B-7E8D-36EC827289A1}"/>
+              <a16:creationId xmlns:a16="http://schemas.microsoft.com/office/drawing/2014/main" id="{CC0771AE-DDF7-2CFC-9BBD-8EB72322912C}"/>
             </a:ext>
           </a:extLst>
         </p:cNvPr>
@@ -3511,7 +3783,7 @@
           <p:cNvPr id="3" name="TextBox 2">
             <a:extLst>
               <a:ext uri="{FF2B5EF4-FFF2-40B4-BE49-F238E27FC236}">
-                <a16:creationId xmlns:a16="http://schemas.microsoft.com/office/drawing/2014/main" id="{E33F16A3-A6E8-401E-847B-09570DC6E4CB}"/>
+                <a16:creationId xmlns:a16="http://schemas.microsoft.com/office/drawing/2014/main" id="{E4136B7E-30F9-F55C-D936-92A857615B3A}"/>
               </a:ext>
             </a:extLst>
           </p:cNvPr>
@@ -3556,10 +3828,845 @@
           </a:p>
         </p:txBody>
       </p:sp>
+      <p:pic>
+        <p:nvPicPr>
+          <p:cNvPr id="4" name="Picture 3">
+            <a:extLst>
+              <a:ext uri="{FF2B5EF4-FFF2-40B4-BE49-F238E27FC236}">
+                <a16:creationId xmlns:a16="http://schemas.microsoft.com/office/drawing/2014/main" id="{5F0F21C7-B093-5042-DF0D-C5A8CC9C8C39}"/>
+              </a:ext>
+            </a:extLst>
+          </p:cNvPr>
+          <p:cNvPicPr>
+            <a:picLocks noChangeAspect="1"/>
+          </p:cNvPicPr>
+          <p:nvPr/>
+        </p:nvPicPr>
+        <p:blipFill>
+          <a:blip r:embed="rId2"/>
+          <a:stretch>
+            <a:fillRect/>
+          </a:stretch>
+        </p:blipFill>
+        <p:spPr>
+          <a:xfrm>
+            <a:off x="1056571" y="2638314"/>
+            <a:ext cx="10078857" cy="1581371"/>
+          </a:xfrm>
+          <a:prstGeom prst="rect">
+            <a:avLst/>
+          </a:prstGeom>
+        </p:spPr>
+      </p:pic>
     </p:spTree>
     <p:extLst>
       <p:ext uri="{BB962C8B-B14F-4D97-AF65-F5344CB8AC3E}">
-        <p14:creationId xmlns:p14="http://schemas.microsoft.com/office/powerpoint/2010/main" val="3095838342"/>
+        <p14:creationId xmlns:p14="http://schemas.microsoft.com/office/powerpoint/2010/main" val="1853459947"/>
+      </p:ext>
+    </p:extLst>
+  </p:cSld>
+  <p:clrMapOvr>
+    <a:masterClrMapping/>
+  </p:clrMapOvr>
+</p:sld>
+</file>
+
+<file path=ppt/slides/slide4.xml><?xml version="1.0" encoding="utf-8"?>
+<p:sld xmlns:a="http://schemas.openxmlformats.org/drawingml/2006/main" xmlns:r="http://schemas.openxmlformats.org/officeDocument/2006/relationships" xmlns:p="http://schemas.openxmlformats.org/presentationml/2006/main">
+  <p:cSld>
+    <p:spTree>
+      <p:nvGrpSpPr>
+        <p:cNvPr id="1" name="">
+          <a:extLst>
+            <a:ext uri="{FF2B5EF4-FFF2-40B4-BE49-F238E27FC236}">
+              <a16:creationId xmlns:a16="http://schemas.microsoft.com/office/drawing/2014/main" id="{DA9B545C-3EAE-F746-8A75-4C31FB061241}"/>
+            </a:ext>
+          </a:extLst>
+        </p:cNvPr>
+        <p:cNvGrpSpPr/>
+        <p:nvPr/>
+      </p:nvGrpSpPr>
+      <p:grpSpPr>
+        <a:xfrm>
+          <a:off x="0" y="0"/>
+          <a:ext cx="0" cy="0"/>
+          <a:chOff x="0" y="0"/>
+          <a:chExt cx="0" cy="0"/>
+        </a:xfrm>
+      </p:grpSpPr>
+      <p:sp>
+        <p:nvSpPr>
+          <p:cNvPr id="3" name="TextBox 2">
+            <a:extLst>
+              <a:ext uri="{FF2B5EF4-FFF2-40B4-BE49-F238E27FC236}">
+                <a16:creationId xmlns:a16="http://schemas.microsoft.com/office/drawing/2014/main" id="{0DDDC6AF-8345-B19C-9C5D-360FC74F779F}"/>
+              </a:ext>
+            </a:extLst>
+          </p:cNvPr>
+          <p:cNvSpPr txBox="1"/>
+          <p:nvPr/>
+        </p:nvSpPr>
+        <p:spPr>
+          <a:xfrm>
+            <a:off x="217714" y="255046"/>
+            <a:ext cx="11756571" cy="355354"/>
+          </a:xfrm>
+          <a:prstGeom prst="rect">
+            <a:avLst/>
+          </a:prstGeom>
+          <a:noFill/>
+        </p:spPr>
+        <p:txBody>
+          <a:bodyPr wrap="square">
+            <a:spAutoFit/>
+          </a:bodyPr>
+          <a:lstStyle/>
+          <a:p>
+            <a:pPr>
+              <a:lnSpc>
+                <a:spcPct val="150000"/>
+              </a:lnSpc>
+              <a:buNone/>
+            </a:pPr>
+            <a:r>
+              <a:rPr lang="en-US" altLang="en-US" sz="1300">
+                <a:latin typeface="Arial" panose="020B0604020202020204" pitchFamily="34" charset="0"/>
+              </a:rPr>
+              <a:t>app\Http\Controllers\Backend\ChildCategoryController.php</a:t>
+            </a:r>
+            <a:endParaRPr kumimoji="0" lang="en-US" altLang="en-US" sz="1300" b="0" i="0" u="none" strike="noStrike" cap="none" normalizeH="0" baseline="0">
+              <a:ln>
+                <a:noFill/>
+              </a:ln>
+              <a:solidFill>
+                <a:schemeClr val="tx1"/>
+              </a:solidFill>
+              <a:effectLst/>
+              <a:latin typeface="Arial" panose="020B0604020202020204" pitchFamily="34" charset="0"/>
+            </a:endParaRPr>
+          </a:p>
+        </p:txBody>
+      </p:sp>
+      <p:pic>
+        <p:nvPicPr>
+          <p:cNvPr id="4" name="Picture 3">
+            <a:extLst>
+              <a:ext uri="{FF2B5EF4-FFF2-40B4-BE49-F238E27FC236}">
+                <a16:creationId xmlns:a16="http://schemas.microsoft.com/office/drawing/2014/main" id="{AB6A64D5-394A-C587-C6E6-4D24E2DAB77A}"/>
+              </a:ext>
+            </a:extLst>
+          </p:cNvPr>
+          <p:cNvPicPr>
+            <a:picLocks noChangeAspect="1"/>
+          </p:cNvPicPr>
+          <p:nvPr/>
+        </p:nvPicPr>
+        <p:blipFill>
+          <a:blip r:embed="rId2"/>
+          <a:stretch>
+            <a:fillRect/>
+          </a:stretch>
+        </p:blipFill>
+        <p:spPr>
+          <a:xfrm>
+            <a:off x="8113701" y="0"/>
+            <a:ext cx="4078299" cy="6858000"/>
+          </a:xfrm>
+          <a:prstGeom prst="rect">
+            <a:avLst/>
+          </a:prstGeom>
+        </p:spPr>
+      </p:pic>
+    </p:spTree>
+    <p:extLst>
+      <p:ext uri="{BB962C8B-B14F-4D97-AF65-F5344CB8AC3E}">
+        <p14:creationId xmlns:p14="http://schemas.microsoft.com/office/powerpoint/2010/main" val="4238990179"/>
+      </p:ext>
+    </p:extLst>
+  </p:cSld>
+  <p:clrMapOvr>
+    <a:masterClrMapping/>
+  </p:clrMapOvr>
+</p:sld>
+</file>
+
+<file path=ppt/slides/slide5.xml><?xml version="1.0" encoding="utf-8"?>
+<p:sld xmlns:a="http://schemas.openxmlformats.org/drawingml/2006/main" xmlns:r="http://schemas.openxmlformats.org/officeDocument/2006/relationships" xmlns:p="http://schemas.openxmlformats.org/presentationml/2006/main">
+  <p:cSld>
+    <p:spTree>
+      <p:nvGrpSpPr>
+        <p:cNvPr id="1" name="">
+          <a:extLst>
+            <a:ext uri="{FF2B5EF4-FFF2-40B4-BE49-F238E27FC236}">
+              <a16:creationId xmlns:a16="http://schemas.microsoft.com/office/drawing/2014/main" id="{1133EEE0-0F6F-418A-72CD-08EB9EB235FD}"/>
+            </a:ext>
+          </a:extLst>
+        </p:cNvPr>
+        <p:cNvGrpSpPr/>
+        <p:nvPr/>
+      </p:nvGrpSpPr>
+      <p:grpSpPr>
+        <a:xfrm>
+          <a:off x="0" y="0"/>
+          <a:ext cx="0" cy="0"/>
+          <a:chOff x="0" y="0"/>
+          <a:chExt cx="0" cy="0"/>
+        </a:xfrm>
+      </p:grpSpPr>
+      <p:sp>
+        <p:nvSpPr>
+          <p:cNvPr id="3" name="TextBox 2">
+            <a:extLst>
+              <a:ext uri="{FF2B5EF4-FFF2-40B4-BE49-F238E27FC236}">
+                <a16:creationId xmlns:a16="http://schemas.microsoft.com/office/drawing/2014/main" id="{0214B0F6-F7F1-F200-4EE5-EED323A66710}"/>
+              </a:ext>
+            </a:extLst>
+          </p:cNvPr>
+          <p:cNvSpPr txBox="1"/>
+          <p:nvPr/>
+        </p:nvSpPr>
+        <p:spPr>
+          <a:xfrm>
+            <a:off x="217714" y="255046"/>
+            <a:ext cx="11756571" cy="355354"/>
+          </a:xfrm>
+          <a:prstGeom prst="rect">
+            <a:avLst/>
+          </a:prstGeom>
+          <a:noFill/>
+        </p:spPr>
+        <p:txBody>
+          <a:bodyPr wrap="square">
+            <a:spAutoFit/>
+          </a:bodyPr>
+          <a:lstStyle/>
+          <a:p>
+            <a:pPr>
+              <a:lnSpc>
+                <a:spcPct val="150000"/>
+              </a:lnSpc>
+              <a:buNone/>
+            </a:pPr>
+            <a:r>
+              <a:rPr kumimoji="0" lang="en-US" altLang="en-US" sz="1300" b="0" i="0" u="none" strike="noStrike" cap="none" normalizeH="0" baseline="0">
+                <a:ln>
+                  <a:noFill/>
+                </a:ln>
+                <a:solidFill>
+                  <a:schemeClr val="tx1"/>
+                </a:solidFill>
+                <a:effectLst/>
+                <a:latin typeface="Arial" panose="020B0604020202020204" pitchFamily="34" charset="0"/>
+              </a:rPr>
+              <a:t>.</a:t>
+            </a:r>
+          </a:p>
+        </p:txBody>
+      </p:sp>
+      <p:pic>
+        <p:nvPicPr>
+          <p:cNvPr id="4" name="Picture 3">
+            <a:extLst>
+              <a:ext uri="{FF2B5EF4-FFF2-40B4-BE49-F238E27FC236}">
+                <a16:creationId xmlns:a16="http://schemas.microsoft.com/office/drawing/2014/main" id="{D81F0B06-5CBB-23F2-A005-66FF202C61C8}"/>
+              </a:ext>
+            </a:extLst>
+          </p:cNvPr>
+          <p:cNvPicPr>
+            <a:picLocks noChangeAspect="1"/>
+          </p:cNvPicPr>
+          <p:nvPr/>
+        </p:nvPicPr>
+        <p:blipFill>
+          <a:blip r:embed="rId2"/>
+          <a:stretch>
+            <a:fillRect/>
+          </a:stretch>
+        </p:blipFill>
+        <p:spPr>
+          <a:xfrm>
+            <a:off x="0" y="0"/>
+            <a:ext cx="4551091" cy="6858000"/>
+          </a:xfrm>
+          <a:prstGeom prst="rect">
+            <a:avLst/>
+          </a:prstGeom>
+          <a:ln w="38100" cap="sq">
+            <a:solidFill>
+              <a:srgbClr val="000000"/>
+            </a:solidFill>
+            <a:prstDash val="solid"/>
+            <a:miter lim="800000"/>
+          </a:ln>
+          <a:effectLst>
+            <a:outerShdw blurRad="50800" dist="38100" dir="2700000" algn="tl" rotWithShape="0">
+              <a:srgbClr val="000000">
+                <a:alpha val="43000"/>
+              </a:srgbClr>
+            </a:outerShdw>
+          </a:effectLst>
+        </p:spPr>
+      </p:pic>
+      <p:pic>
+        <p:nvPicPr>
+          <p:cNvPr id="6" name="Picture 5">
+            <a:extLst>
+              <a:ext uri="{FF2B5EF4-FFF2-40B4-BE49-F238E27FC236}">
+                <a16:creationId xmlns:a16="http://schemas.microsoft.com/office/drawing/2014/main" id="{7589E8DD-EBA0-0315-133A-8ABCC368790A}"/>
+              </a:ext>
+            </a:extLst>
+          </p:cNvPr>
+          <p:cNvPicPr>
+            <a:picLocks noChangeAspect="1"/>
+          </p:cNvPicPr>
+          <p:nvPr/>
+        </p:nvPicPr>
+        <p:blipFill>
+          <a:blip r:embed="rId3"/>
+          <a:srcRect r="10768" b="22801"/>
+          <a:stretch>
+            <a:fillRect/>
+          </a:stretch>
+        </p:blipFill>
+        <p:spPr>
+          <a:xfrm>
+            <a:off x="5747159" y="2180181"/>
+            <a:ext cx="6430838" cy="2152073"/>
+          </a:xfrm>
+          <a:prstGeom prst="rect">
+            <a:avLst/>
+          </a:prstGeom>
+          <a:ln w="38100" cap="sq">
+            <a:solidFill>
+              <a:srgbClr val="000000"/>
+            </a:solidFill>
+            <a:prstDash val="solid"/>
+            <a:miter lim="800000"/>
+          </a:ln>
+          <a:effectLst>
+            <a:outerShdw blurRad="50800" dist="38100" dir="2700000" algn="tl" rotWithShape="0">
+              <a:srgbClr val="000000">
+                <a:alpha val="43000"/>
+              </a:srgbClr>
+            </a:outerShdw>
+          </a:effectLst>
+        </p:spPr>
+      </p:pic>
+      <p:sp>
+        <p:nvSpPr>
+          <p:cNvPr id="7" name="Arrow: Right 6">
+            <a:extLst>
+              <a:ext uri="{FF2B5EF4-FFF2-40B4-BE49-F238E27FC236}">
+                <a16:creationId xmlns:a16="http://schemas.microsoft.com/office/drawing/2014/main" id="{ACFD27E0-E605-2D0B-961B-C5E220A75EF6}"/>
+              </a:ext>
+            </a:extLst>
+          </p:cNvPr>
+          <p:cNvSpPr/>
+          <p:nvPr/>
+        </p:nvSpPr>
+        <p:spPr>
+          <a:xfrm>
+            <a:off x="4890507" y="3017227"/>
+            <a:ext cx="517236" cy="477982"/>
+          </a:xfrm>
+          <a:prstGeom prst="rightArrow">
+            <a:avLst/>
+          </a:prstGeom>
+        </p:spPr>
+        <p:style>
+          <a:lnRef idx="2">
+            <a:schemeClr val="dk1">
+              <a:shade val="15000"/>
+            </a:schemeClr>
+          </a:lnRef>
+          <a:fillRef idx="1">
+            <a:schemeClr val="dk1"/>
+          </a:fillRef>
+          <a:effectRef idx="0">
+            <a:schemeClr val="dk1"/>
+          </a:effectRef>
+          <a:fontRef idx="minor">
+            <a:schemeClr val="lt1"/>
+          </a:fontRef>
+        </p:style>
+        <p:txBody>
+          <a:bodyPr rtlCol="0" anchor="ctr"/>
+          <a:lstStyle/>
+          <a:p>
+            <a:pPr algn="ctr"/>
+            <a:endParaRPr lang="en-US"/>
+          </a:p>
+        </p:txBody>
+      </p:sp>
+    </p:spTree>
+    <p:extLst>
+      <p:ext uri="{BB962C8B-B14F-4D97-AF65-F5344CB8AC3E}">
+        <p14:creationId xmlns:p14="http://schemas.microsoft.com/office/powerpoint/2010/main" val="673066343"/>
+      </p:ext>
+    </p:extLst>
+  </p:cSld>
+  <p:clrMapOvr>
+    <a:masterClrMapping/>
+  </p:clrMapOvr>
+</p:sld>
+</file>
+
+<file path=ppt/slides/slide6.xml><?xml version="1.0" encoding="utf-8"?>
+<p:sld xmlns:a="http://schemas.openxmlformats.org/drawingml/2006/main" xmlns:r="http://schemas.openxmlformats.org/officeDocument/2006/relationships" xmlns:p="http://schemas.openxmlformats.org/presentationml/2006/main">
+  <p:cSld>
+    <p:spTree>
+      <p:nvGrpSpPr>
+        <p:cNvPr id="1" name="">
+          <a:extLst>
+            <a:ext uri="{FF2B5EF4-FFF2-40B4-BE49-F238E27FC236}">
+              <a16:creationId xmlns:a16="http://schemas.microsoft.com/office/drawing/2014/main" id="{BB0AA7F1-C9AC-8F97-5EBB-67645514BBA0}"/>
+            </a:ext>
+          </a:extLst>
+        </p:cNvPr>
+        <p:cNvGrpSpPr/>
+        <p:nvPr/>
+      </p:nvGrpSpPr>
+      <p:grpSpPr>
+        <a:xfrm>
+          <a:off x="0" y="0"/>
+          <a:ext cx="0" cy="0"/>
+          <a:chOff x="0" y="0"/>
+          <a:chExt cx="0" cy="0"/>
+        </a:xfrm>
+      </p:grpSpPr>
+      <p:sp>
+        <p:nvSpPr>
+          <p:cNvPr id="3" name="TextBox 2">
+            <a:extLst>
+              <a:ext uri="{FF2B5EF4-FFF2-40B4-BE49-F238E27FC236}">
+                <a16:creationId xmlns:a16="http://schemas.microsoft.com/office/drawing/2014/main" id="{70BE0963-4809-C267-EA47-7E423CA2F7BB}"/>
+              </a:ext>
+            </a:extLst>
+          </p:cNvPr>
+          <p:cNvSpPr txBox="1"/>
+          <p:nvPr/>
+        </p:nvSpPr>
+        <p:spPr>
+          <a:xfrm>
+            <a:off x="217714" y="255046"/>
+            <a:ext cx="11756571" cy="355354"/>
+          </a:xfrm>
+          <a:prstGeom prst="rect">
+            <a:avLst/>
+          </a:prstGeom>
+          <a:noFill/>
+        </p:spPr>
+        <p:txBody>
+          <a:bodyPr wrap="square">
+            <a:spAutoFit/>
+          </a:bodyPr>
+          <a:lstStyle/>
+          <a:p>
+            <a:pPr>
+              <a:lnSpc>
+                <a:spcPct val="150000"/>
+              </a:lnSpc>
+              <a:buNone/>
+            </a:pPr>
+            <a:r>
+              <a:rPr lang="en-US" altLang="en-US" sz="1300">
+                <a:latin typeface="Arial" panose="020B0604020202020204" pitchFamily="34" charset="0"/>
+              </a:rPr>
+              <a:t>app\Http\Controllers\Backend\ChildCategoryController.php</a:t>
+            </a:r>
+            <a:endParaRPr kumimoji="0" lang="en-US" altLang="en-US" sz="1300" b="0" i="0" u="none" strike="noStrike" cap="none" normalizeH="0" baseline="0">
+              <a:ln>
+                <a:noFill/>
+              </a:ln>
+              <a:solidFill>
+                <a:schemeClr val="tx1"/>
+              </a:solidFill>
+              <a:effectLst/>
+              <a:latin typeface="Arial" panose="020B0604020202020204" pitchFamily="34" charset="0"/>
+            </a:endParaRPr>
+          </a:p>
+        </p:txBody>
+      </p:sp>
+      <p:pic>
+        <p:nvPicPr>
+          <p:cNvPr id="4" name="Picture 3">
+            <a:extLst>
+              <a:ext uri="{FF2B5EF4-FFF2-40B4-BE49-F238E27FC236}">
+                <a16:creationId xmlns:a16="http://schemas.microsoft.com/office/drawing/2014/main" id="{EA6487E3-6E2C-38A7-0FB4-A9E989D3000C}"/>
+              </a:ext>
+            </a:extLst>
+          </p:cNvPr>
+          <p:cNvPicPr>
+            <a:picLocks noChangeAspect="1"/>
+          </p:cNvPicPr>
+          <p:nvPr/>
+        </p:nvPicPr>
+        <p:blipFill>
+          <a:blip r:embed="rId2"/>
+          <a:stretch>
+            <a:fillRect/>
+          </a:stretch>
+        </p:blipFill>
+        <p:spPr>
+          <a:xfrm>
+            <a:off x="7404469" y="0"/>
+            <a:ext cx="4787531" cy="6858000"/>
+          </a:xfrm>
+          <a:prstGeom prst="rect">
+            <a:avLst/>
+          </a:prstGeom>
+        </p:spPr>
+      </p:pic>
+    </p:spTree>
+    <p:extLst>
+      <p:ext uri="{BB962C8B-B14F-4D97-AF65-F5344CB8AC3E}">
+        <p14:creationId xmlns:p14="http://schemas.microsoft.com/office/powerpoint/2010/main" val="2249398617"/>
+      </p:ext>
+    </p:extLst>
+  </p:cSld>
+  <p:clrMapOvr>
+    <a:masterClrMapping/>
+  </p:clrMapOvr>
+</p:sld>
+</file>
+
+<file path=ppt/slides/slide7.xml><?xml version="1.0" encoding="utf-8"?>
+<p:sld xmlns:a="http://schemas.openxmlformats.org/drawingml/2006/main" xmlns:r="http://schemas.openxmlformats.org/officeDocument/2006/relationships" xmlns:p="http://schemas.openxmlformats.org/presentationml/2006/main">
+  <p:cSld>
+    <p:spTree>
+      <p:nvGrpSpPr>
+        <p:cNvPr id="1" name="">
+          <a:extLst>
+            <a:ext uri="{FF2B5EF4-FFF2-40B4-BE49-F238E27FC236}">
+              <a16:creationId xmlns:a16="http://schemas.microsoft.com/office/drawing/2014/main" id="{B8A25950-EE05-5072-8296-E6E644D42B43}"/>
+            </a:ext>
+          </a:extLst>
+        </p:cNvPr>
+        <p:cNvGrpSpPr/>
+        <p:nvPr/>
+      </p:nvGrpSpPr>
+      <p:grpSpPr>
+        <a:xfrm>
+          <a:off x="0" y="0"/>
+          <a:ext cx="0" cy="0"/>
+          <a:chOff x="0" y="0"/>
+          <a:chExt cx="0" cy="0"/>
+        </a:xfrm>
+      </p:grpSpPr>
+      <p:sp>
+        <p:nvSpPr>
+          <p:cNvPr id="3" name="TextBox 2">
+            <a:extLst>
+              <a:ext uri="{FF2B5EF4-FFF2-40B4-BE49-F238E27FC236}">
+                <a16:creationId xmlns:a16="http://schemas.microsoft.com/office/drawing/2014/main" id="{5724256B-9107-3B3B-126F-286F01E8DF3A}"/>
+              </a:ext>
+            </a:extLst>
+          </p:cNvPr>
+          <p:cNvSpPr txBox="1"/>
+          <p:nvPr/>
+        </p:nvSpPr>
+        <p:spPr>
+          <a:xfrm>
+            <a:off x="217714" y="255046"/>
+            <a:ext cx="11756571" cy="355354"/>
+          </a:xfrm>
+          <a:prstGeom prst="rect">
+            <a:avLst/>
+          </a:prstGeom>
+          <a:noFill/>
+        </p:spPr>
+        <p:txBody>
+          <a:bodyPr wrap="square">
+            <a:spAutoFit/>
+          </a:bodyPr>
+          <a:lstStyle/>
+          <a:p>
+            <a:pPr>
+              <a:lnSpc>
+                <a:spcPct val="150000"/>
+              </a:lnSpc>
+              <a:buNone/>
+            </a:pPr>
+            <a:r>
+              <a:rPr kumimoji="0" lang="en-US" altLang="en-US" sz="1300" b="0" i="0" u="none" strike="noStrike" cap="none" normalizeH="0" baseline="0">
+                <a:ln>
+                  <a:noFill/>
+                </a:ln>
+                <a:solidFill>
+                  <a:schemeClr val="tx1"/>
+                </a:solidFill>
+                <a:effectLst/>
+                <a:latin typeface="Arial" panose="020B0604020202020204" pitchFamily="34" charset="0"/>
+              </a:rPr>
+              <a:t>.</a:t>
+            </a:r>
+          </a:p>
+        </p:txBody>
+      </p:sp>
+      <p:pic>
+        <p:nvPicPr>
+          <p:cNvPr id="4" name="Picture 3">
+            <a:extLst>
+              <a:ext uri="{FF2B5EF4-FFF2-40B4-BE49-F238E27FC236}">
+                <a16:creationId xmlns:a16="http://schemas.microsoft.com/office/drawing/2014/main" id="{8FA1FD8D-60FB-2DCA-2D26-60670E9B6059}"/>
+              </a:ext>
+            </a:extLst>
+          </p:cNvPr>
+          <p:cNvPicPr>
+            <a:picLocks noChangeAspect="1"/>
+          </p:cNvPicPr>
+          <p:nvPr/>
+        </p:nvPicPr>
+        <p:blipFill>
+          <a:blip r:embed="rId2"/>
+          <a:stretch>
+            <a:fillRect/>
+          </a:stretch>
+        </p:blipFill>
+        <p:spPr>
+          <a:xfrm>
+            <a:off x="3209084" y="0"/>
+            <a:ext cx="5773830" cy="6858000"/>
+          </a:xfrm>
+          <a:prstGeom prst="rect">
+            <a:avLst/>
+          </a:prstGeom>
+          <a:ln w="38100" cap="sq">
+            <a:solidFill>
+              <a:srgbClr val="000000"/>
+            </a:solidFill>
+            <a:prstDash val="solid"/>
+            <a:miter lim="800000"/>
+          </a:ln>
+          <a:effectLst>
+            <a:outerShdw blurRad="50800" dist="38100" dir="2700000" algn="tl" rotWithShape="0">
+              <a:srgbClr val="000000">
+                <a:alpha val="43000"/>
+              </a:srgbClr>
+            </a:outerShdw>
+          </a:effectLst>
+        </p:spPr>
+      </p:pic>
+    </p:spTree>
+    <p:extLst>
+      <p:ext uri="{BB962C8B-B14F-4D97-AF65-F5344CB8AC3E}">
+        <p14:creationId xmlns:p14="http://schemas.microsoft.com/office/powerpoint/2010/main" val="3188667831"/>
+      </p:ext>
+    </p:extLst>
+  </p:cSld>
+  <p:clrMapOvr>
+    <a:masterClrMapping/>
+  </p:clrMapOvr>
+</p:sld>
+</file>
+
+<file path=ppt/slides/slide8.xml><?xml version="1.0" encoding="utf-8"?>
+<p:sld xmlns:a="http://schemas.openxmlformats.org/drawingml/2006/main" xmlns:r="http://schemas.openxmlformats.org/officeDocument/2006/relationships" xmlns:p="http://schemas.openxmlformats.org/presentationml/2006/main">
+  <p:cSld>
+    <p:spTree>
+      <p:nvGrpSpPr>
+        <p:cNvPr id="1" name="">
+          <a:extLst>
+            <a:ext uri="{FF2B5EF4-FFF2-40B4-BE49-F238E27FC236}">
+              <a16:creationId xmlns:a16="http://schemas.microsoft.com/office/drawing/2014/main" id="{D9B359F9-0FA4-247A-03A4-7A6C61B21FA1}"/>
+            </a:ext>
+          </a:extLst>
+        </p:cNvPr>
+        <p:cNvGrpSpPr/>
+        <p:nvPr/>
+      </p:nvGrpSpPr>
+      <p:grpSpPr>
+        <a:xfrm>
+          <a:off x="0" y="0"/>
+          <a:ext cx="0" cy="0"/>
+          <a:chOff x="0" y="0"/>
+          <a:chExt cx="0" cy="0"/>
+        </a:xfrm>
+      </p:grpSpPr>
+      <p:sp>
+        <p:nvSpPr>
+          <p:cNvPr id="3" name="TextBox 2">
+            <a:extLst>
+              <a:ext uri="{FF2B5EF4-FFF2-40B4-BE49-F238E27FC236}">
+                <a16:creationId xmlns:a16="http://schemas.microsoft.com/office/drawing/2014/main" id="{E529F723-CF18-6ACE-82E1-02EA05186C3A}"/>
+              </a:ext>
+            </a:extLst>
+          </p:cNvPr>
+          <p:cNvSpPr txBox="1"/>
+          <p:nvPr/>
+        </p:nvSpPr>
+        <p:spPr>
+          <a:xfrm>
+            <a:off x="217714" y="255046"/>
+            <a:ext cx="11756571" cy="355354"/>
+          </a:xfrm>
+          <a:prstGeom prst="rect">
+            <a:avLst/>
+          </a:prstGeom>
+          <a:noFill/>
+        </p:spPr>
+        <p:txBody>
+          <a:bodyPr wrap="square">
+            <a:spAutoFit/>
+          </a:bodyPr>
+          <a:lstStyle/>
+          <a:p>
+            <a:pPr>
+              <a:lnSpc>
+                <a:spcPct val="150000"/>
+              </a:lnSpc>
+              <a:buNone/>
+            </a:pPr>
+            <a:r>
+              <a:rPr kumimoji="0" lang="en-US" altLang="en-US" sz="1300" b="0" i="0" u="none" strike="noStrike" cap="none" normalizeH="0" baseline="0">
+                <a:ln>
+                  <a:noFill/>
+                </a:ln>
+                <a:solidFill>
+                  <a:schemeClr val="tx1"/>
+                </a:solidFill>
+                <a:effectLst/>
+                <a:latin typeface="Arial" panose="020B0604020202020204" pitchFamily="34" charset="0"/>
+              </a:rPr>
+              <a:t>.</a:t>
+            </a:r>
+          </a:p>
+        </p:txBody>
+      </p:sp>
+      <p:pic>
+        <p:nvPicPr>
+          <p:cNvPr id="4" name="Picture 3">
+            <a:extLst>
+              <a:ext uri="{FF2B5EF4-FFF2-40B4-BE49-F238E27FC236}">
+                <a16:creationId xmlns:a16="http://schemas.microsoft.com/office/drawing/2014/main" id="{F658D701-2C41-C1F3-05F5-EB8284782D7F}"/>
+              </a:ext>
+            </a:extLst>
+          </p:cNvPr>
+          <p:cNvPicPr>
+            <a:picLocks noChangeAspect="1"/>
+          </p:cNvPicPr>
+          <p:nvPr/>
+        </p:nvPicPr>
+        <p:blipFill>
+          <a:blip r:embed="rId2"/>
+          <a:stretch>
+            <a:fillRect/>
+          </a:stretch>
+        </p:blipFill>
+        <p:spPr>
+          <a:xfrm>
+            <a:off x="-1" y="1599247"/>
+            <a:ext cx="12192000" cy="3659506"/>
+          </a:xfrm>
+          <a:prstGeom prst="rect">
+            <a:avLst/>
+          </a:prstGeom>
+          <a:ln w="38100" cap="sq">
+            <a:solidFill>
+              <a:srgbClr val="000000"/>
+            </a:solidFill>
+            <a:prstDash val="solid"/>
+            <a:miter lim="800000"/>
+          </a:ln>
+          <a:effectLst>
+            <a:outerShdw blurRad="50800" dist="38100" dir="2700000" algn="tl" rotWithShape="0">
+              <a:srgbClr val="000000">
+                <a:alpha val="43000"/>
+              </a:srgbClr>
+            </a:outerShdw>
+          </a:effectLst>
+        </p:spPr>
+      </p:pic>
+    </p:spTree>
+    <p:extLst>
+      <p:ext uri="{BB962C8B-B14F-4D97-AF65-F5344CB8AC3E}">
+        <p14:creationId xmlns:p14="http://schemas.microsoft.com/office/powerpoint/2010/main" val="3767048469"/>
+      </p:ext>
+    </p:extLst>
+  </p:cSld>
+  <p:clrMapOvr>
+    <a:masterClrMapping/>
+  </p:clrMapOvr>
+</p:sld>
+</file>
+
+<file path=ppt/slides/slide9.xml><?xml version="1.0" encoding="utf-8"?>
+<p:sld xmlns:a="http://schemas.openxmlformats.org/drawingml/2006/main" xmlns:r="http://schemas.openxmlformats.org/officeDocument/2006/relationships" xmlns:p="http://schemas.openxmlformats.org/presentationml/2006/main">
+  <p:cSld>
+    <p:spTree>
+      <p:nvGrpSpPr>
+        <p:cNvPr id="1" name="">
+          <a:extLst>
+            <a:ext uri="{FF2B5EF4-FFF2-40B4-BE49-F238E27FC236}">
+              <a16:creationId xmlns:a16="http://schemas.microsoft.com/office/drawing/2014/main" id="{EBE97844-1D98-49B8-F11C-58F095DCF661}"/>
+            </a:ext>
+          </a:extLst>
+        </p:cNvPr>
+        <p:cNvGrpSpPr/>
+        <p:nvPr/>
+      </p:nvGrpSpPr>
+      <p:grpSpPr>
+        <a:xfrm>
+          <a:off x="0" y="0"/>
+          <a:ext cx="0" cy="0"/>
+          <a:chOff x="0" y="0"/>
+          <a:chExt cx="0" cy="0"/>
+        </a:xfrm>
+      </p:grpSpPr>
+      <p:sp>
+        <p:nvSpPr>
+          <p:cNvPr id="3" name="TextBox 2">
+            <a:extLst>
+              <a:ext uri="{FF2B5EF4-FFF2-40B4-BE49-F238E27FC236}">
+                <a16:creationId xmlns:a16="http://schemas.microsoft.com/office/drawing/2014/main" id="{2C2F0EC4-6B51-94ED-F601-043F380CC3E5}"/>
+              </a:ext>
+            </a:extLst>
+          </p:cNvPr>
+          <p:cNvSpPr txBox="1"/>
+          <p:nvPr/>
+        </p:nvSpPr>
+        <p:spPr>
+          <a:xfrm>
+            <a:off x="217714" y="255046"/>
+            <a:ext cx="11756571" cy="355354"/>
+          </a:xfrm>
+          <a:prstGeom prst="rect">
+            <a:avLst/>
+          </a:prstGeom>
+          <a:noFill/>
+        </p:spPr>
+        <p:txBody>
+          <a:bodyPr wrap="square">
+            <a:spAutoFit/>
+          </a:bodyPr>
+          <a:lstStyle/>
+          <a:p>
+            <a:pPr>
+              <a:lnSpc>
+                <a:spcPct val="150000"/>
+              </a:lnSpc>
+              <a:buNone/>
+            </a:pPr>
+            <a:r>
+              <a:rPr kumimoji="0" lang="en-US" altLang="en-US" sz="1300" b="0" i="0" u="none" strike="noStrike" cap="none" normalizeH="0" baseline="0">
+                <a:ln>
+                  <a:noFill/>
+                </a:ln>
+                <a:solidFill>
+                  <a:schemeClr val="tx1"/>
+                </a:solidFill>
+                <a:effectLst/>
+                <a:latin typeface="Arial" panose="020B0604020202020204" pitchFamily="34" charset="0"/>
+              </a:rPr>
+              <a:t>.</a:t>
+            </a:r>
+          </a:p>
+        </p:txBody>
+      </p:sp>
+    </p:spTree>
+    <p:extLst>
+      <p:ext uri="{BB962C8B-B14F-4D97-AF65-F5344CB8AC3E}">
+        <p14:creationId xmlns:p14="http://schemas.microsoft.com/office/powerpoint/2010/main" val="233363963"/>
       </p:ext>
     </p:extLst>
   </p:cSld>

</xml_diff>